<commit_message>
Use native Streamlit Space deployment
</commit_message>
<xml_diff>
--- a/outputs/Tourism_Package_Prediction_MLOps_Presentation.pptx
+++ b/outputs/Tourism_Package_Prediction_MLOps_Presentation.pptx
@@ -2,51 +2,51 @@
 <file path=ppt/presentation.xml><?xml version="1.0" encoding="utf-8"?>
 <p:presentation xmlns:p="http://schemas.openxmlformats.org/presentationml/2006/main" embedTrueTypeFonts="1" saveSubsetFonts="0">
   <p:sldMasterIdLst>
-    <p:sldMasterId xmlns:r="http://schemas.openxmlformats.org/officeDocument/2006/relationships" id="2147483648" r:id="Rf244a36900ff4055"/>
-    <p:sldMasterId xmlns:r="http://schemas.openxmlformats.org/officeDocument/2006/relationships" id="2147483660" r:id="R4c87a80d5c6c4914"/>
+    <p:sldMasterId xmlns:r="http://schemas.openxmlformats.org/officeDocument/2006/relationships" id="2147483648" r:id="R12d1703e906340b8"/>
+    <p:sldMasterId xmlns:r="http://schemas.openxmlformats.org/officeDocument/2006/relationships" id="2147483660" r:id="R89aa717df4324d2a"/>
   </p:sldMasterIdLst>
   <p:notesMasterIdLst>
-    <p:notesMasterId xmlns:r="http://schemas.openxmlformats.org/officeDocument/2006/relationships" r:id="R3c35130384ba4c53"/>
+    <p:notesMasterId xmlns:r="http://schemas.openxmlformats.org/officeDocument/2006/relationships" r:id="R2151f859f89b4a97"/>
   </p:notesMasterIdLst>
   <p:sldIdLst>
-    <p:sldId xmlns:r="http://schemas.openxmlformats.org/officeDocument/2006/relationships" id="256" r:id="R084a3217198d46c5"/>
-    <p:sldId xmlns:r="http://schemas.openxmlformats.org/officeDocument/2006/relationships" id="257" r:id="R8491d09695784460"/>
-    <p:sldId xmlns:r="http://schemas.openxmlformats.org/officeDocument/2006/relationships" id="258" r:id="R75feffd400234d84"/>
-    <p:sldId xmlns:r="http://schemas.openxmlformats.org/officeDocument/2006/relationships" id="259" r:id="R0513edf91e0c48d0"/>
-    <p:sldId xmlns:r="http://schemas.openxmlformats.org/officeDocument/2006/relationships" id="260" r:id="R0a9d0b9be0d54d8b"/>
-    <p:sldId xmlns:r="http://schemas.openxmlformats.org/officeDocument/2006/relationships" id="261" r:id="R939ba70e13c149b4"/>
-    <p:sldId xmlns:r="http://schemas.openxmlformats.org/officeDocument/2006/relationships" id="262" r:id="R7a181769110748b9"/>
-    <p:sldId xmlns:r="http://schemas.openxmlformats.org/officeDocument/2006/relationships" id="263" r:id="R616484835c934b43"/>
-    <p:sldId xmlns:r="http://schemas.openxmlformats.org/officeDocument/2006/relationships" id="264" r:id="Raa5b408d5ce74698"/>
-    <p:sldId xmlns:r="http://schemas.openxmlformats.org/officeDocument/2006/relationships" id="265" r:id="R12fbf5aa4da24c35"/>
-    <p:sldId xmlns:r="http://schemas.openxmlformats.org/officeDocument/2006/relationships" id="266" r:id="Rfc0a7f25da2a40cb"/>
-    <p:sldId xmlns:r="http://schemas.openxmlformats.org/officeDocument/2006/relationships" id="267" r:id="R0683bdcb79ac47c9"/>
-    <p:sldId xmlns:r="http://schemas.openxmlformats.org/officeDocument/2006/relationships" id="268" r:id="Rfc07fa88858a4818"/>
-    <p:sldId xmlns:r="http://schemas.openxmlformats.org/officeDocument/2006/relationships" id="269" r:id="R9b300731b0f14e20"/>
-    <p:sldId xmlns:r="http://schemas.openxmlformats.org/officeDocument/2006/relationships" id="270" r:id="R6d14eaa441ba4ba9"/>
-    <p:sldId xmlns:r="http://schemas.openxmlformats.org/officeDocument/2006/relationships" id="271" r:id="R4a7934fdecac45ec"/>
+    <p:sldId xmlns:r="http://schemas.openxmlformats.org/officeDocument/2006/relationships" id="256" r:id="Ra8fe67c1400c4691"/>
+    <p:sldId xmlns:r="http://schemas.openxmlformats.org/officeDocument/2006/relationships" id="257" r:id="R656dcf5020ae4147"/>
+    <p:sldId xmlns:r="http://schemas.openxmlformats.org/officeDocument/2006/relationships" id="258" r:id="Racff931de0e44949"/>
+    <p:sldId xmlns:r="http://schemas.openxmlformats.org/officeDocument/2006/relationships" id="259" r:id="R142f87a6b2914729"/>
+    <p:sldId xmlns:r="http://schemas.openxmlformats.org/officeDocument/2006/relationships" id="260" r:id="R4be2d63066154dba"/>
+    <p:sldId xmlns:r="http://schemas.openxmlformats.org/officeDocument/2006/relationships" id="261" r:id="R53582ea207394f42"/>
+    <p:sldId xmlns:r="http://schemas.openxmlformats.org/officeDocument/2006/relationships" id="262" r:id="R4d18d07bc8734c7f"/>
+    <p:sldId xmlns:r="http://schemas.openxmlformats.org/officeDocument/2006/relationships" id="263" r:id="Rd2767dcb71364b0e"/>
+    <p:sldId xmlns:r="http://schemas.openxmlformats.org/officeDocument/2006/relationships" id="264" r:id="R82c70b0f6d734ea0"/>
+    <p:sldId xmlns:r="http://schemas.openxmlformats.org/officeDocument/2006/relationships" id="265" r:id="R4ef8b7269851446a"/>
+    <p:sldId xmlns:r="http://schemas.openxmlformats.org/officeDocument/2006/relationships" id="266" r:id="R45b92208f48a415e"/>
+    <p:sldId xmlns:r="http://schemas.openxmlformats.org/officeDocument/2006/relationships" id="267" r:id="R19a59aa41ffb4caf"/>
+    <p:sldId xmlns:r="http://schemas.openxmlformats.org/officeDocument/2006/relationships" id="268" r:id="R188c0703dcc743ed"/>
+    <p:sldId xmlns:r="http://schemas.openxmlformats.org/officeDocument/2006/relationships" id="269" r:id="R539f19e286eb40df"/>
+    <p:sldId xmlns:r="http://schemas.openxmlformats.org/officeDocument/2006/relationships" id="270" r:id="R4fd41e3bfc174a43"/>
+    <p:sldId xmlns:r="http://schemas.openxmlformats.org/officeDocument/2006/relationships" id="271" r:id="R4e2e4730a9fa4e7c"/>
   </p:sldIdLst>
   <p:sldSz cx="9144000" cy="5143500"/>
   <p:notesSz cx="6858000" cy="9144000"/>
   <p:embeddedFontLst>
     <p:embeddedFont>
       <p:font typeface="Nunito SemiBold"/>
-      <p:regular xmlns:r="http://schemas.openxmlformats.org/officeDocument/2006/relationships" r:id="R4cc041205abd4195"/>
-      <p:bold xmlns:r="http://schemas.openxmlformats.org/officeDocument/2006/relationships" r:id="R8886f9f7836d47c4"/>
-      <p:italic xmlns:r="http://schemas.openxmlformats.org/officeDocument/2006/relationships" r:id="Ra4fe71959136437e"/>
-      <p:boldItalic xmlns:r="http://schemas.openxmlformats.org/officeDocument/2006/relationships" r:id="Re603cf94905147da"/>
+      <p:regular xmlns:r="http://schemas.openxmlformats.org/officeDocument/2006/relationships" r:id="R3d96ab86a2f7421d"/>
+      <p:bold xmlns:r="http://schemas.openxmlformats.org/officeDocument/2006/relationships" r:id="R8f603572c6a24d39"/>
+      <p:italic xmlns:r="http://schemas.openxmlformats.org/officeDocument/2006/relationships" r:id="R0a1a87a56e254cfc"/>
+      <p:boldItalic xmlns:r="http://schemas.openxmlformats.org/officeDocument/2006/relationships" r:id="R9a918c21575e4c40"/>
     </p:embeddedFont>
     <p:embeddedFont>
       <p:font typeface="Nunito"/>
-      <p:regular xmlns:r="http://schemas.openxmlformats.org/officeDocument/2006/relationships" r:id="R452ce603f5194f25"/>
-      <p:bold xmlns:r="http://schemas.openxmlformats.org/officeDocument/2006/relationships" r:id="R6ee0e62028194a31"/>
-      <p:italic xmlns:r="http://schemas.openxmlformats.org/officeDocument/2006/relationships" r:id="R87b0595bf9694f6d"/>
-      <p:boldItalic xmlns:r="http://schemas.openxmlformats.org/officeDocument/2006/relationships" r:id="Rc574fade44b649a3"/>
+      <p:regular xmlns:r="http://schemas.openxmlformats.org/officeDocument/2006/relationships" r:id="Rc5375e4e3c4c4cdb"/>
+      <p:bold xmlns:r="http://schemas.openxmlformats.org/officeDocument/2006/relationships" r:id="Re56e8490276b420f"/>
+      <p:italic xmlns:r="http://schemas.openxmlformats.org/officeDocument/2006/relationships" r:id="R5fce3af166c64c34"/>
+      <p:boldItalic xmlns:r="http://schemas.openxmlformats.org/officeDocument/2006/relationships" r:id="Rec7a9067f394432f"/>
     </p:embeddedFont>
     <p:embeddedFont>
       <p:font typeface="Nunito ExtraBold"/>
-      <p:bold xmlns:r="http://schemas.openxmlformats.org/officeDocument/2006/relationships" r:id="R5f7354f98dbf478c"/>
-      <p:boldItalic xmlns:r="http://schemas.openxmlformats.org/officeDocument/2006/relationships" r:id="Rd03f15a27e31496f"/>
+      <p:bold xmlns:r="http://schemas.openxmlformats.org/officeDocument/2006/relationships" r:id="R49d5236f4f6f4d67"/>
+      <p:boldItalic xmlns:r="http://schemas.openxmlformats.org/officeDocument/2006/relationships" r:id="R4346a17f03ba4b29"/>
     </p:embeddedFont>
   </p:embeddedFontLst>
 </p:presentation>
@@ -4176,7 +4176,7 @@
           <p:nvPr/>
         </p:nvPicPr>
         <p:blipFill rotWithShape="1">
-          <a:blip xmlns:r="http://schemas.openxmlformats.org/officeDocument/2006/relationships" xmlns:a="http://schemas.openxmlformats.org/drawingml/2006/main" r:embed="R3be1d2a8a27d49b9">
+          <a:blip xmlns:r="http://schemas.openxmlformats.org/officeDocument/2006/relationships" xmlns:a="http://schemas.openxmlformats.org/drawingml/2006/main" r:embed="R13830c639a3c4e9e">
             <a:alphaModFix/>
           </a:blip>
           <a:srcRect xmlns:a="http://schemas.openxmlformats.org/drawingml/2006/main" l="42816" t="18359" r="37297" b="19152"/>
@@ -4503,7 +4503,7 @@
           <p:nvPr/>
         </p:nvPicPr>
         <p:blipFill rotWithShape="1">
-          <a:blip xmlns:r="http://schemas.openxmlformats.org/officeDocument/2006/relationships" xmlns:a="http://schemas.openxmlformats.org/drawingml/2006/main" r:embed="Rb8c1fa186d1c462f">
+          <a:blip xmlns:r="http://schemas.openxmlformats.org/officeDocument/2006/relationships" xmlns:a="http://schemas.openxmlformats.org/drawingml/2006/main" r:embed="R8b8cfa8a4ff3472c">
             <a:alphaModFix/>
           </a:blip>
           <a:srcRect xmlns:a="http://schemas.openxmlformats.org/drawingml/2006/main" l="0" t="0" r="0" b="0"/>
@@ -13028,17 +13028,17 @@
   </p:cSld>
   <p:clrMap bg1="lt1" tx1="dk1" bg2="dk2" tx2="lt2" accent1="accent1" accent2="accent2" accent3="accent3" accent4="accent4" accent5="accent5" accent6="accent6" hlink="hlink" folHlink="folHlink"/>
   <p:sldLayoutIdLst>
-    <p:sldLayoutId xmlns:r="http://schemas.openxmlformats.org/officeDocument/2006/relationships" id="2147483649" r:id="Rdbd7c767147b4c78"/>
-    <p:sldLayoutId xmlns:r="http://schemas.openxmlformats.org/officeDocument/2006/relationships" id="2147483650" r:id="R0538c0b3eb044078"/>
-    <p:sldLayoutId xmlns:r="http://schemas.openxmlformats.org/officeDocument/2006/relationships" id="2147483651" r:id="R7bc5f106c5e64427"/>
-    <p:sldLayoutId xmlns:r="http://schemas.openxmlformats.org/officeDocument/2006/relationships" id="2147483652" r:id="R51dfc436ae424e09"/>
-    <p:sldLayoutId xmlns:r="http://schemas.openxmlformats.org/officeDocument/2006/relationships" id="2147483653" r:id="R53432b27a1de4c50"/>
-    <p:sldLayoutId xmlns:r="http://schemas.openxmlformats.org/officeDocument/2006/relationships" id="2147483654" r:id="R971dd61cd2b84399"/>
-    <p:sldLayoutId xmlns:r="http://schemas.openxmlformats.org/officeDocument/2006/relationships" id="2147483655" r:id="R0471dd723df94a58"/>
-    <p:sldLayoutId xmlns:r="http://schemas.openxmlformats.org/officeDocument/2006/relationships" id="2147483656" r:id="R7de6fe20bd724cbb"/>
-    <p:sldLayoutId xmlns:r="http://schemas.openxmlformats.org/officeDocument/2006/relationships" id="2147483657" r:id="Rfe3474d0abea4529"/>
-    <p:sldLayoutId xmlns:r="http://schemas.openxmlformats.org/officeDocument/2006/relationships" id="2147483658" r:id="R487c7a15a7134fc4"/>
-    <p:sldLayoutId xmlns:r="http://schemas.openxmlformats.org/officeDocument/2006/relationships" id="2147483659" r:id="R6beb9fe025184f43"/>
+    <p:sldLayoutId xmlns:r="http://schemas.openxmlformats.org/officeDocument/2006/relationships" id="2147483649" r:id="R2603c1d97c2f4dfd"/>
+    <p:sldLayoutId xmlns:r="http://schemas.openxmlformats.org/officeDocument/2006/relationships" id="2147483650" r:id="Rd70098dc87e14a88"/>
+    <p:sldLayoutId xmlns:r="http://schemas.openxmlformats.org/officeDocument/2006/relationships" id="2147483651" r:id="R33542dc1f99d4ff3"/>
+    <p:sldLayoutId xmlns:r="http://schemas.openxmlformats.org/officeDocument/2006/relationships" id="2147483652" r:id="R31cee99df82749fc"/>
+    <p:sldLayoutId xmlns:r="http://schemas.openxmlformats.org/officeDocument/2006/relationships" id="2147483653" r:id="Rb337bb0d69b14e2d"/>
+    <p:sldLayoutId xmlns:r="http://schemas.openxmlformats.org/officeDocument/2006/relationships" id="2147483654" r:id="R1179593a9f5e4ba4"/>
+    <p:sldLayoutId xmlns:r="http://schemas.openxmlformats.org/officeDocument/2006/relationships" id="2147483655" r:id="Rfb87525b5f2a4833"/>
+    <p:sldLayoutId xmlns:r="http://schemas.openxmlformats.org/officeDocument/2006/relationships" id="2147483656" r:id="Reb459495ad0b415a"/>
+    <p:sldLayoutId xmlns:r="http://schemas.openxmlformats.org/officeDocument/2006/relationships" id="2147483657" r:id="R7b811ff943534043"/>
+    <p:sldLayoutId xmlns:r="http://schemas.openxmlformats.org/officeDocument/2006/relationships" id="2147483658" r:id="R94dbd51698a54c09"/>
+    <p:sldLayoutId xmlns:r="http://schemas.openxmlformats.org/officeDocument/2006/relationships" id="2147483659" r:id="R9c8935607d5a463b"/>
   </p:sldLayoutIdLst>
   <p:hf sldNum="0" hdr="0" ftr="0" dt="0"/>
   <p:txStyles>
@@ -14603,7 +14603,7 @@
           <p:nvPr/>
         </p:nvPicPr>
         <p:blipFill rotWithShape="1">
-          <a:blip xmlns:r="http://schemas.openxmlformats.org/officeDocument/2006/relationships" xmlns:a="http://schemas.openxmlformats.org/drawingml/2006/main" r:embed="R446303632c4648e7">
+          <a:blip xmlns:r="http://schemas.openxmlformats.org/officeDocument/2006/relationships" xmlns:a="http://schemas.openxmlformats.org/drawingml/2006/main" r:embed="Rba594ab98cb449f4">
             <a:alphaModFix/>
           </a:blip>
           <a:srcRect xmlns:a="http://schemas.openxmlformats.org/drawingml/2006/main" l="0" t="0" r="0" b="0"/>
@@ -14758,16 +14758,16 @@
   </p:cSld>
   <p:clrMap bg1="lt1" tx1="dk1" bg2="dk2" tx2="lt2" accent1="accent1" accent2="accent2" accent3="accent3" accent4="accent4" accent5="accent5" accent6="accent6" hlink="hlink" folHlink="folHlink"/>
   <p:sldLayoutIdLst>
-    <p:sldLayoutId xmlns:r="http://schemas.openxmlformats.org/officeDocument/2006/relationships" id="2147483661" r:id="Re5c5ab8ee44044c9"/>
-    <p:sldLayoutId xmlns:r="http://schemas.openxmlformats.org/officeDocument/2006/relationships" id="2147483662" r:id="Rcc08ae3677764886"/>
-    <p:sldLayoutId xmlns:r="http://schemas.openxmlformats.org/officeDocument/2006/relationships" id="2147483663" r:id="Raee04de14f2c4292"/>
-    <p:sldLayoutId xmlns:r="http://schemas.openxmlformats.org/officeDocument/2006/relationships" id="2147483664" r:id="R9db6255598b54bb4"/>
-    <p:sldLayoutId xmlns:r="http://schemas.openxmlformats.org/officeDocument/2006/relationships" id="2147483665" r:id="Rd3803f91c355463c"/>
-    <p:sldLayoutId xmlns:r="http://schemas.openxmlformats.org/officeDocument/2006/relationships" id="2147483666" r:id="Rec7b8fe71eda41ec"/>
-    <p:sldLayoutId xmlns:r="http://schemas.openxmlformats.org/officeDocument/2006/relationships" id="2147483667" r:id="Rd06edc3f747b40f8"/>
-    <p:sldLayoutId xmlns:r="http://schemas.openxmlformats.org/officeDocument/2006/relationships" id="2147483668" r:id="R7d59ac8c9b3c4219"/>
-    <p:sldLayoutId xmlns:r="http://schemas.openxmlformats.org/officeDocument/2006/relationships" id="2147483669" r:id="R5c78ee4333ff40e2"/>
-    <p:sldLayoutId xmlns:r="http://schemas.openxmlformats.org/officeDocument/2006/relationships" id="2147483670" r:id="R22746be61ba84528"/>
+    <p:sldLayoutId xmlns:r="http://schemas.openxmlformats.org/officeDocument/2006/relationships" id="2147483661" r:id="Ra73159d6d6a848a8"/>
+    <p:sldLayoutId xmlns:r="http://schemas.openxmlformats.org/officeDocument/2006/relationships" id="2147483662" r:id="R7900be7b8af245a8"/>
+    <p:sldLayoutId xmlns:r="http://schemas.openxmlformats.org/officeDocument/2006/relationships" id="2147483663" r:id="R3b62141c1ca24229"/>
+    <p:sldLayoutId xmlns:r="http://schemas.openxmlformats.org/officeDocument/2006/relationships" id="2147483664" r:id="Rf8500857f58945c6"/>
+    <p:sldLayoutId xmlns:r="http://schemas.openxmlformats.org/officeDocument/2006/relationships" id="2147483665" r:id="Ra1ffc644b6d2447a"/>
+    <p:sldLayoutId xmlns:r="http://schemas.openxmlformats.org/officeDocument/2006/relationships" id="2147483666" r:id="Radee7aacb4644249"/>
+    <p:sldLayoutId xmlns:r="http://schemas.openxmlformats.org/officeDocument/2006/relationships" id="2147483667" r:id="R3e5e75757c454cf0"/>
+    <p:sldLayoutId xmlns:r="http://schemas.openxmlformats.org/officeDocument/2006/relationships" id="2147483668" r:id="Raba723257cde47fc"/>
+    <p:sldLayoutId xmlns:r="http://schemas.openxmlformats.org/officeDocument/2006/relationships" id="2147483669" r:id="R77d18edb305942b6"/>
+    <p:sldLayoutId xmlns:r="http://schemas.openxmlformats.org/officeDocument/2006/relationships" id="2147483670" r:id="R048849b9ddca4049"/>
   </p:sldLayoutIdLst>
   <p:hf sldNum="0" hdr="0" ftr="0" dt="0"/>
   <p:txStyles>
@@ -16359,7 +16359,7 @@
                   <a:srgbClr val="1B1B1B"/>
                 </a:solidFill>
               </a:rPr>
-              <a:t>•  Deployment surface: Streamlit app packaged with a Dockerfile for Hugging Face Spaces.</a:t>
+              <a:t>•  Deployment surface: Streamlit app on Hugging Face Spaces, with Dockerfile configuration retained for portability.</a:t>
             </a:r>
           </a:p>
           <a:p xmlns:a="http://schemas.openxmlformats.org/drawingml/2006/main">
@@ -16947,7 +16947,7 @@
           <p:nvPr/>
         </p:nvPicPr>
         <p:blipFill rotWithShape="1">
-          <a:blip xmlns:r="http://schemas.openxmlformats.org/officeDocument/2006/relationships" xmlns:a="http://schemas.openxmlformats.org/drawingml/2006/main" r:embed="R7db24fbe7ef445a8">
+          <a:blip xmlns:r="http://schemas.openxmlformats.org/officeDocument/2006/relationships" xmlns:a="http://schemas.openxmlformats.org/drawingml/2006/main" r:embed="R2b42b333731240d2">
             <a:alphaModFix/>
           </a:blip>
           <a:srcRect xmlns:a="http://schemas.openxmlformats.org/drawingml/2006/main" l="0" t="0" r="0" b="0"/>

</xml_diff>

<commit_message>
Use Docker Space for Streamlit deployment
</commit_message>
<xml_diff>
--- a/outputs/Tourism_Package_Prediction_MLOps_Presentation.pptx
+++ b/outputs/Tourism_Package_Prediction_MLOps_Presentation.pptx
@@ -2,51 +2,51 @@
 <file path=ppt/presentation.xml><?xml version="1.0" encoding="utf-8"?>
 <p:presentation xmlns:p="http://schemas.openxmlformats.org/presentationml/2006/main" embedTrueTypeFonts="1" saveSubsetFonts="0">
   <p:sldMasterIdLst>
-    <p:sldMasterId xmlns:r="http://schemas.openxmlformats.org/officeDocument/2006/relationships" id="2147483648" r:id="R12d1703e906340b8"/>
-    <p:sldMasterId xmlns:r="http://schemas.openxmlformats.org/officeDocument/2006/relationships" id="2147483660" r:id="R89aa717df4324d2a"/>
+    <p:sldMasterId xmlns:r="http://schemas.openxmlformats.org/officeDocument/2006/relationships" id="2147483648" r:id="R0aba1b11a9d64f9f"/>
+    <p:sldMasterId xmlns:r="http://schemas.openxmlformats.org/officeDocument/2006/relationships" id="2147483660" r:id="Reaf5e8f8ab654937"/>
   </p:sldMasterIdLst>
   <p:notesMasterIdLst>
-    <p:notesMasterId xmlns:r="http://schemas.openxmlformats.org/officeDocument/2006/relationships" r:id="R2151f859f89b4a97"/>
+    <p:notesMasterId xmlns:r="http://schemas.openxmlformats.org/officeDocument/2006/relationships" r:id="R746dfcb5e48447cc"/>
   </p:notesMasterIdLst>
   <p:sldIdLst>
-    <p:sldId xmlns:r="http://schemas.openxmlformats.org/officeDocument/2006/relationships" id="256" r:id="Ra8fe67c1400c4691"/>
-    <p:sldId xmlns:r="http://schemas.openxmlformats.org/officeDocument/2006/relationships" id="257" r:id="R656dcf5020ae4147"/>
-    <p:sldId xmlns:r="http://schemas.openxmlformats.org/officeDocument/2006/relationships" id="258" r:id="Racff931de0e44949"/>
-    <p:sldId xmlns:r="http://schemas.openxmlformats.org/officeDocument/2006/relationships" id="259" r:id="R142f87a6b2914729"/>
-    <p:sldId xmlns:r="http://schemas.openxmlformats.org/officeDocument/2006/relationships" id="260" r:id="R4be2d63066154dba"/>
-    <p:sldId xmlns:r="http://schemas.openxmlformats.org/officeDocument/2006/relationships" id="261" r:id="R53582ea207394f42"/>
-    <p:sldId xmlns:r="http://schemas.openxmlformats.org/officeDocument/2006/relationships" id="262" r:id="R4d18d07bc8734c7f"/>
-    <p:sldId xmlns:r="http://schemas.openxmlformats.org/officeDocument/2006/relationships" id="263" r:id="Rd2767dcb71364b0e"/>
-    <p:sldId xmlns:r="http://schemas.openxmlformats.org/officeDocument/2006/relationships" id="264" r:id="R82c70b0f6d734ea0"/>
-    <p:sldId xmlns:r="http://schemas.openxmlformats.org/officeDocument/2006/relationships" id="265" r:id="R4ef8b7269851446a"/>
-    <p:sldId xmlns:r="http://schemas.openxmlformats.org/officeDocument/2006/relationships" id="266" r:id="R45b92208f48a415e"/>
-    <p:sldId xmlns:r="http://schemas.openxmlformats.org/officeDocument/2006/relationships" id="267" r:id="R19a59aa41ffb4caf"/>
-    <p:sldId xmlns:r="http://schemas.openxmlformats.org/officeDocument/2006/relationships" id="268" r:id="R188c0703dcc743ed"/>
-    <p:sldId xmlns:r="http://schemas.openxmlformats.org/officeDocument/2006/relationships" id="269" r:id="R539f19e286eb40df"/>
-    <p:sldId xmlns:r="http://schemas.openxmlformats.org/officeDocument/2006/relationships" id="270" r:id="R4fd41e3bfc174a43"/>
-    <p:sldId xmlns:r="http://schemas.openxmlformats.org/officeDocument/2006/relationships" id="271" r:id="R4e2e4730a9fa4e7c"/>
+    <p:sldId xmlns:r="http://schemas.openxmlformats.org/officeDocument/2006/relationships" id="256" r:id="R9de49475163c486b"/>
+    <p:sldId xmlns:r="http://schemas.openxmlformats.org/officeDocument/2006/relationships" id="257" r:id="R72d98433ad914cf8"/>
+    <p:sldId xmlns:r="http://schemas.openxmlformats.org/officeDocument/2006/relationships" id="258" r:id="R8f5b513de0364b0f"/>
+    <p:sldId xmlns:r="http://schemas.openxmlformats.org/officeDocument/2006/relationships" id="259" r:id="Re397a97a4641416c"/>
+    <p:sldId xmlns:r="http://schemas.openxmlformats.org/officeDocument/2006/relationships" id="260" r:id="R56fcd688c3d64933"/>
+    <p:sldId xmlns:r="http://schemas.openxmlformats.org/officeDocument/2006/relationships" id="261" r:id="Rb8e3ac7d1f814e7c"/>
+    <p:sldId xmlns:r="http://schemas.openxmlformats.org/officeDocument/2006/relationships" id="262" r:id="Refedeecfdfdd4658"/>
+    <p:sldId xmlns:r="http://schemas.openxmlformats.org/officeDocument/2006/relationships" id="263" r:id="R33bb1919dfa54003"/>
+    <p:sldId xmlns:r="http://schemas.openxmlformats.org/officeDocument/2006/relationships" id="264" r:id="R9fc633dc34d146e8"/>
+    <p:sldId xmlns:r="http://schemas.openxmlformats.org/officeDocument/2006/relationships" id="265" r:id="Re4d389c74ad94e5b"/>
+    <p:sldId xmlns:r="http://schemas.openxmlformats.org/officeDocument/2006/relationships" id="266" r:id="R755e4c1f86c145f1"/>
+    <p:sldId xmlns:r="http://schemas.openxmlformats.org/officeDocument/2006/relationships" id="267" r:id="R538a516d70994754"/>
+    <p:sldId xmlns:r="http://schemas.openxmlformats.org/officeDocument/2006/relationships" id="268" r:id="Re5600155523c4682"/>
+    <p:sldId xmlns:r="http://schemas.openxmlformats.org/officeDocument/2006/relationships" id="269" r:id="Rcf1855c076bb4ecf"/>
+    <p:sldId xmlns:r="http://schemas.openxmlformats.org/officeDocument/2006/relationships" id="270" r:id="Ra7ebb346ef294e73"/>
+    <p:sldId xmlns:r="http://schemas.openxmlformats.org/officeDocument/2006/relationships" id="271" r:id="R8710197082414c32"/>
   </p:sldIdLst>
   <p:sldSz cx="9144000" cy="5143500"/>
   <p:notesSz cx="6858000" cy="9144000"/>
   <p:embeddedFontLst>
     <p:embeddedFont>
       <p:font typeface="Nunito SemiBold"/>
-      <p:regular xmlns:r="http://schemas.openxmlformats.org/officeDocument/2006/relationships" r:id="R3d96ab86a2f7421d"/>
-      <p:bold xmlns:r="http://schemas.openxmlformats.org/officeDocument/2006/relationships" r:id="R8f603572c6a24d39"/>
-      <p:italic xmlns:r="http://schemas.openxmlformats.org/officeDocument/2006/relationships" r:id="R0a1a87a56e254cfc"/>
-      <p:boldItalic xmlns:r="http://schemas.openxmlformats.org/officeDocument/2006/relationships" r:id="R9a918c21575e4c40"/>
+      <p:regular xmlns:r="http://schemas.openxmlformats.org/officeDocument/2006/relationships" r:id="Re905cf3332df4ae9"/>
+      <p:bold xmlns:r="http://schemas.openxmlformats.org/officeDocument/2006/relationships" r:id="R4a6739e7ae3a433b"/>
+      <p:italic xmlns:r="http://schemas.openxmlformats.org/officeDocument/2006/relationships" r:id="R24ba4534808d4c49"/>
+      <p:boldItalic xmlns:r="http://schemas.openxmlformats.org/officeDocument/2006/relationships" r:id="R8c466b2471874306"/>
     </p:embeddedFont>
     <p:embeddedFont>
       <p:font typeface="Nunito"/>
-      <p:regular xmlns:r="http://schemas.openxmlformats.org/officeDocument/2006/relationships" r:id="Rc5375e4e3c4c4cdb"/>
-      <p:bold xmlns:r="http://schemas.openxmlformats.org/officeDocument/2006/relationships" r:id="Re56e8490276b420f"/>
-      <p:italic xmlns:r="http://schemas.openxmlformats.org/officeDocument/2006/relationships" r:id="R5fce3af166c64c34"/>
-      <p:boldItalic xmlns:r="http://schemas.openxmlformats.org/officeDocument/2006/relationships" r:id="Rec7a9067f394432f"/>
+      <p:regular xmlns:r="http://schemas.openxmlformats.org/officeDocument/2006/relationships" r:id="R1134dd2e46164822"/>
+      <p:bold xmlns:r="http://schemas.openxmlformats.org/officeDocument/2006/relationships" r:id="R1b143b8f69a44e45"/>
+      <p:italic xmlns:r="http://schemas.openxmlformats.org/officeDocument/2006/relationships" r:id="R44c11e4098a14a37"/>
+      <p:boldItalic xmlns:r="http://schemas.openxmlformats.org/officeDocument/2006/relationships" r:id="R26f0e551679f4e26"/>
     </p:embeddedFont>
     <p:embeddedFont>
       <p:font typeface="Nunito ExtraBold"/>
-      <p:bold xmlns:r="http://schemas.openxmlformats.org/officeDocument/2006/relationships" r:id="R49d5236f4f6f4d67"/>
-      <p:boldItalic xmlns:r="http://schemas.openxmlformats.org/officeDocument/2006/relationships" r:id="R4346a17f03ba4b29"/>
+      <p:bold xmlns:r="http://schemas.openxmlformats.org/officeDocument/2006/relationships" r:id="R7ace0557626f419a"/>
+      <p:boldItalic xmlns:r="http://schemas.openxmlformats.org/officeDocument/2006/relationships" r:id="Ra4f51b829c914f6d"/>
     </p:embeddedFont>
   </p:embeddedFontLst>
 </p:presentation>
@@ -4176,7 +4176,7 @@
           <p:nvPr/>
         </p:nvPicPr>
         <p:blipFill rotWithShape="1">
-          <a:blip xmlns:r="http://schemas.openxmlformats.org/officeDocument/2006/relationships" xmlns:a="http://schemas.openxmlformats.org/drawingml/2006/main" r:embed="R13830c639a3c4e9e">
+          <a:blip xmlns:r="http://schemas.openxmlformats.org/officeDocument/2006/relationships" xmlns:a="http://schemas.openxmlformats.org/drawingml/2006/main" r:embed="R61933f65c03d4066">
             <a:alphaModFix/>
           </a:blip>
           <a:srcRect xmlns:a="http://schemas.openxmlformats.org/drawingml/2006/main" l="42816" t="18359" r="37297" b="19152"/>
@@ -4503,7 +4503,7 @@
           <p:nvPr/>
         </p:nvPicPr>
         <p:blipFill rotWithShape="1">
-          <a:blip xmlns:r="http://schemas.openxmlformats.org/officeDocument/2006/relationships" xmlns:a="http://schemas.openxmlformats.org/drawingml/2006/main" r:embed="R8b8cfa8a4ff3472c">
+          <a:blip xmlns:r="http://schemas.openxmlformats.org/officeDocument/2006/relationships" xmlns:a="http://schemas.openxmlformats.org/drawingml/2006/main" r:embed="Rcaa32d713922459a">
             <a:alphaModFix/>
           </a:blip>
           <a:srcRect xmlns:a="http://schemas.openxmlformats.org/drawingml/2006/main" l="0" t="0" r="0" b="0"/>
@@ -13028,17 +13028,17 @@
   </p:cSld>
   <p:clrMap bg1="lt1" tx1="dk1" bg2="dk2" tx2="lt2" accent1="accent1" accent2="accent2" accent3="accent3" accent4="accent4" accent5="accent5" accent6="accent6" hlink="hlink" folHlink="folHlink"/>
   <p:sldLayoutIdLst>
-    <p:sldLayoutId xmlns:r="http://schemas.openxmlformats.org/officeDocument/2006/relationships" id="2147483649" r:id="R2603c1d97c2f4dfd"/>
-    <p:sldLayoutId xmlns:r="http://schemas.openxmlformats.org/officeDocument/2006/relationships" id="2147483650" r:id="Rd70098dc87e14a88"/>
-    <p:sldLayoutId xmlns:r="http://schemas.openxmlformats.org/officeDocument/2006/relationships" id="2147483651" r:id="R33542dc1f99d4ff3"/>
-    <p:sldLayoutId xmlns:r="http://schemas.openxmlformats.org/officeDocument/2006/relationships" id="2147483652" r:id="R31cee99df82749fc"/>
-    <p:sldLayoutId xmlns:r="http://schemas.openxmlformats.org/officeDocument/2006/relationships" id="2147483653" r:id="Rb337bb0d69b14e2d"/>
-    <p:sldLayoutId xmlns:r="http://schemas.openxmlformats.org/officeDocument/2006/relationships" id="2147483654" r:id="R1179593a9f5e4ba4"/>
-    <p:sldLayoutId xmlns:r="http://schemas.openxmlformats.org/officeDocument/2006/relationships" id="2147483655" r:id="Rfb87525b5f2a4833"/>
-    <p:sldLayoutId xmlns:r="http://schemas.openxmlformats.org/officeDocument/2006/relationships" id="2147483656" r:id="Reb459495ad0b415a"/>
-    <p:sldLayoutId xmlns:r="http://schemas.openxmlformats.org/officeDocument/2006/relationships" id="2147483657" r:id="R7b811ff943534043"/>
-    <p:sldLayoutId xmlns:r="http://schemas.openxmlformats.org/officeDocument/2006/relationships" id="2147483658" r:id="R94dbd51698a54c09"/>
-    <p:sldLayoutId xmlns:r="http://schemas.openxmlformats.org/officeDocument/2006/relationships" id="2147483659" r:id="R9c8935607d5a463b"/>
+    <p:sldLayoutId xmlns:r="http://schemas.openxmlformats.org/officeDocument/2006/relationships" id="2147483649" r:id="R96e5c51f57264256"/>
+    <p:sldLayoutId xmlns:r="http://schemas.openxmlformats.org/officeDocument/2006/relationships" id="2147483650" r:id="R9733a20547c14fba"/>
+    <p:sldLayoutId xmlns:r="http://schemas.openxmlformats.org/officeDocument/2006/relationships" id="2147483651" r:id="R303c4e61983b4ac5"/>
+    <p:sldLayoutId xmlns:r="http://schemas.openxmlformats.org/officeDocument/2006/relationships" id="2147483652" r:id="R8a311f71ef914d27"/>
+    <p:sldLayoutId xmlns:r="http://schemas.openxmlformats.org/officeDocument/2006/relationships" id="2147483653" r:id="R38b414e382c44710"/>
+    <p:sldLayoutId xmlns:r="http://schemas.openxmlformats.org/officeDocument/2006/relationships" id="2147483654" r:id="R0f7749c45ef24cbe"/>
+    <p:sldLayoutId xmlns:r="http://schemas.openxmlformats.org/officeDocument/2006/relationships" id="2147483655" r:id="Rc2c0eca44a8448c4"/>
+    <p:sldLayoutId xmlns:r="http://schemas.openxmlformats.org/officeDocument/2006/relationships" id="2147483656" r:id="Re42ab44341e142ad"/>
+    <p:sldLayoutId xmlns:r="http://schemas.openxmlformats.org/officeDocument/2006/relationships" id="2147483657" r:id="Re3afd29db9514ad1"/>
+    <p:sldLayoutId xmlns:r="http://schemas.openxmlformats.org/officeDocument/2006/relationships" id="2147483658" r:id="Rac086b42c31c44ec"/>
+    <p:sldLayoutId xmlns:r="http://schemas.openxmlformats.org/officeDocument/2006/relationships" id="2147483659" r:id="R41e66fdc480247f6"/>
   </p:sldLayoutIdLst>
   <p:hf sldNum="0" hdr="0" ftr="0" dt="0"/>
   <p:txStyles>
@@ -14603,7 +14603,7 @@
           <p:nvPr/>
         </p:nvPicPr>
         <p:blipFill rotWithShape="1">
-          <a:blip xmlns:r="http://schemas.openxmlformats.org/officeDocument/2006/relationships" xmlns:a="http://schemas.openxmlformats.org/drawingml/2006/main" r:embed="Rba594ab98cb449f4">
+          <a:blip xmlns:r="http://schemas.openxmlformats.org/officeDocument/2006/relationships" xmlns:a="http://schemas.openxmlformats.org/drawingml/2006/main" r:embed="R4f7c0f02ad8e4005">
             <a:alphaModFix/>
           </a:blip>
           <a:srcRect xmlns:a="http://schemas.openxmlformats.org/drawingml/2006/main" l="0" t="0" r="0" b="0"/>
@@ -14758,16 +14758,16 @@
   </p:cSld>
   <p:clrMap bg1="lt1" tx1="dk1" bg2="dk2" tx2="lt2" accent1="accent1" accent2="accent2" accent3="accent3" accent4="accent4" accent5="accent5" accent6="accent6" hlink="hlink" folHlink="folHlink"/>
   <p:sldLayoutIdLst>
-    <p:sldLayoutId xmlns:r="http://schemas.openxmlformats.org/officeDocument/2006/relationships" id="2147483661" r:id="Ra73159d6d6a848a8"/>
-    <p:sldLayoutId xmlns:r="http://schemas.openxmlformats.org/officeDocument/2006/relationships" id="2147483662" r:id="R7900be7b8af245a8"/>
-    <p:sldLayoutId xmlns:r="http://schemas.openxmlformats.org/officeDocument/2006/relationships" id="2147483663" r:id="R3b62141c1ca24229"/>
-    <p:sldLayoutId xmlns:r="http://schemas.openxmlformats.org/officeDocument/2006/relationships" id="2147483664" r:id="Rf8500857f58945c6"/>
-    <p:sldLayoutId xmlns:r="http://schemas.openxmlformats.org/officeDocument/2006/relationships" id="2147483665" r:id="Ra1ffc644b6d2447a"/>
-    <p:sldLayoutId xmlns:r="http://schemas.openxmlformats.org/officeDocument/2006/relationships" id="2147483666" r:id="Radee7aacb4644249"/>
-    <p:sldLayoutId xmlns:r="http://schemas.openxmlformats.org/officeDocument/2006/relationships" id="2147483667" r:id="R3e5e75757c454cf0"/>
-    <p:sldLayoutId xmlns:r="http://schemas.openxmlformats.org/officeDocument/2006/relationships" id="2147483668" r:id="Raba723257cde47fc"/>
-    <p:sldLayoutId xmlns:r="http://schemas.openxmlformats.org/officeDocument/2006/relationships" id="2147483669" r:id="R77d18edb305942b6"/>
-    <p:sldLayoutId xmlns:r="http://schemas.openxmlformats.org/officeDocument/2006/relationships" id="2147483670" r:id="R048849b9ddca4049"/>
+    <p:sldLayoutId xmlns:r="http://schemas.openxmlformats.org/officeDocument/2006/relationships" id="2147483661" r:id="R77d1c79bc0b84aba"/>
+    <p:sldLayoutId xmlns:r="http://schemas.openxmlformats.org/officeDocument/2006/relationships" id="2147483662" r:id="Rb6b02f496e4e4088"/>
+    <p:sldLayoutId xmlns:r="http://schemas.openxmlformats.org/officeDocument/2006/relationships" id="2147483663" r:id="Red9a54882378489a"/>
+    <p:sldLayoutId xmlns:r="http://schemas.openxmlformats.org/officeDocument/2006/relationships" id="2147483664" r:id="R189c56501abf49c2"/>
+    <p:sldLayoutId xmlns:r="http://schemas.openxmlformats.org/officeDocument/2006/relationships" id="2147483665" r:id="Raf2ad7522fda456c"/>
+    <p:sldLayoutId xmlns:r="http://schemas.openxmlformats.org/officeDocument/2006/relationships" id="2147483666" r:id="R17b0633c69904070"/>
+    <p:sldLayoutId xmlns:r="http://schemas.openxmlformats.org/officeDocument/2006/relationships" id="2147483667" r:id="R8e8af4d7df194664"/>
+    <p:sldLayoutId xmlns:r="http://schemas.openxmlformats.org/officeDocument/2006/relationships" id="2147483668" r:id="R239fa25572714edf"/>
+    <p:sldLayoutId xmlns:r="http://schemas.openxmlformats.org/officeDocument/2006/relationships" id="2147483669" r:id="Red16c12068e847ba"/>
+    <p:sldLayoutId xmlns:r="http://schemas.openxmlformats.org/officeDocument/2006/relationships" id="2147483670" r:id="R30fa8972cc82468b"/>
   </p:sldLayoutIdLst>
   <p:hf sldNum="0" hdr="0" ftr="0" dt="0"/>
   <p:txStyles>
@@ -16359,7 +16359,7 @@
                   <a:srgbClr val="1B1B1B"/>
                 </a:solidFill>
               </a:rPr>
-              <a:t>•  Deployment surface: Streamlit app on Hugging Face Spaces, with Dockerfile configuration retained for portability.</a:t>
+              <a:t>•  Deployment surface: Streamlit app packaged with a Dockerfile for Hugging Face Spaces.</a:t>
             </a:r>
           </a:p>
           <a:p xmlns:a="http://schemas.openxmlformats.org/drawingml/2006/main">
@@ -16947,7 +16947,7 @@
           <p:nvPr/>
         </p:nvPicPr>
         <p:blipFill rotWithShape="1">
-          <a:blip xmlns:r="http://schemas.openxmlformats.org/officeDocument/2006/relationships" xmlns:a="http://schemas.openxmlformats.org/drawingml/2006/main" r:embed="R2b42b333731240d2">
+          <a:blip xmlns:r="http://schemas.openxmlformats.org/officeDocument/2006/relationships" xmlns:a="http://schemas.openxmlformats.org/drawingml/2006/main" r:embed="R2a77bf71dad9442c">
             <a:alphaModFix/>
           </a:blip>
           <a:srcRect xmlns:a="http://schemas.openxmlformats.org/drawingml/2006/main" l="0" t="0" r="0" b="0"/>

</xml_diff>

<commit_message>
Add free deployment path for project app
</commit_message>
<xml_diff>
--- a/outputs/Tourism_Package_Prediction_MLOps_Presentation.pptx
+++ b/outputs/Tourism_Package_Prediction_MLOps_Presentation.pptx
@@ -2,51 +2,51 @@
 <file path=ppt/presentation.xml><?xml version="1.0" encoding="utf-8"?>
 <p:presentation xmlns:p="http://schemas.openxmlformats.org/presentationml/2006/main" embedTrueTypeFonts="1" saveSubsetFonts="0">
   <p:sldMasterIdLst>
-    <p:sldMasterId xmlns:r="http://schemas.openxmlformats.org/officeDocument/2006/relationships" id="2147483648" r:id="R0aba1b11a9d64f9f"/>
-    <p:sldMasterId xmlns:r="http://schemas.openxmlformats.org/officeDocument/2006/relationships" id="2147483660" r:id="Reaf5e8f8ab654937"/>
+    <p:sldMasterId xmlns:r="http://schemas.openxmlformats.org/officeDocument/2006/relationships" id="2147483648" r:id="R6ecbe781cc3e4fa4"/>
+    <p:sldMasterId xmlns:r="http://schemas.openxmlformats.org/officeDocument/2006/relationships" id="2147483660" r:id="Re2dbbe2ce9174107"/>
   </p:sldMasterIdLst>
   <p:notesMasterIdLst>
-    <p:notesMasterId xmlns:r="http://schemas.openxmlformats.org/officeDocument/2006/relationships" r:id="R746dfcb5e48447cc"/>
+    <p:notesMasterId xmlns:r="http://schemas.openxmlformats.org/officeDocument/2006/relationships" r:id="R0104423212574fce"/>
   </p:notesMasterIdLst>
   <p:sldIdLst>
-    <p:sldId xmlns:r="http://schemas.openxmlformats.org/officeDocument/2006/relationships" id="256" r:id="R9de49475163c486b"/>
-    <p:sldId xmlns:r="http://schemas.openxmlformats.org/officeDocument/2006/relationships" id="257" r:id="R72d98433ad914cf8"/>
-    <p:sldId xmlns:r="http://schemas.openxmlformats.org/officeDocument/2006/relationships" id="258" r:id="R8f5b513de0364b0f"/>
-    <p:sldId xmlns:r="http://schemas.openxmlformats.org/officeDocument/2006/relationships" id="259" r:id="Re397a97a4641416c"/>
-    <p:sldId xmlns:r="http://schemas.openxmlformats.org/officeDocument/2006/relationships" id="260" r:id="R56fcd688c3d64933"/>
-    <p:sldId xmlns:r="http://schemas.openxmlformats.org/officeDocument/2006/relationships" id="261" r:id="Rb8e3ac7d1f814e7c"/>
-    <p:sldId xmlns:r="http://schemas.openxmlformats.org/officeDocument/2006/relationships" id="262" r:id="Refedeecfdfdd4658"/>
-    <p:sldId xmlns:r="http://schemas.openxmlformats.org/officeDocument/2006/relationships" id="263" r:id="R33bb1919dfa54003"/>
-    <p:sldId xmlns:r="http://schemas.openxmlformats.org/officeDocument/2006/relationships" id="264" r:id="R9fc633dc34d146e8"/>
-    <p:sldId xmlns:r="http://schemas.openxmlformats.org/officeDocument/2006/relationships" id="265" r:id="Re4d389c74ad94e5b"/>
-    <p:sldId xmlns:r="http://schemas.openxmlformats.org/officeDocument/2006/relationships" id="266" r:id="R755e4c1f86c145f1"/>
-    <p:sldId xmlns:r="http://schemas.openxmlformats.org/officeDocument/2006/relationships" id="267" r:id="R538a516d70994754"/>
-    <p:sldId xmlns:r="http://schemas.openxmlformats.org/officeDocument/2006/relationships" id="268" r:id="Re5600155523c4682"/>
-    <p:sldId xmlns:r="http://schemas.openxmlformats.org/officeDocument/2006/relationships" id="269" r:id="Rcf1855c076bb4ecf"/>
-    <p:sldId xmlns:r="http://schemas.openxmlformats.org/officeDocument/2006/relationships" id="270" r:id="Ra7ebb346ef294e73"/>
-    <p:sldId xmlns:r="http://schemas.openxmlformats.org/officeDocument/2006/relationships" id="271" r:id="R8710197082414c32"/>
+    <p:sldId xmlns:r="http://schemas.openxmlformats.org/officeDocument/2006/relationships" id="256" r:id="R21c414457cec49e0"/>
+    <p:sldId xmlns:r="http://schemas.openxmlformats.org/officeDocument/2006/relationships" id="257" r:id="R9c042e80e6ac4199"/>
+    <p:sldId xmlns:r="http://schemas.openxmlformats.org/officeDocument/2006/relationships" id="258" r:id="R4eb60b7d8fd042b6"/>
+    <p:sldId xmlns:r="http://schemas.openxmlformats.org/officeDocument/2006/relationships" id="259" r:id="R029cf779b10145cb"/>
+    <p:sldId xmlns:r="http://schemas.openxmlformats.org/officeDocument/2006/relationships" id="260" r:id="R46bf652208e34f61"/>
+    <p:sldId xmlns:r="http://schemas.openxmlformats.org/officeDocument/2006/relationships" id="261" r:id="Rfef4724c865040e1"/>
+    <p:sldId xmlns:r="http://schemas.openxmlformats.org/officeDocument/2006/relationships" id="262" r:id="R7de64c30f1a5403b"/>
+    <p:sldId xmlns:r="http://schemas.openxmlformats.org/officeDocument/2006/relationships" id="263" r:id="Re586b86f4ce24024"/>
+    <p:sldId xmlns:r="http://schemas.openxmlformats.org/officeDocument/2006/relationships" id="264" r:id="Rb73b3c61c3074ef7"/>
+    <p:sldId xmlns:r="http://schemas.openxmlformats.org/officeDocument/2006/relationships" id="265" r:id="R304a934d9b4149b1"/>
+    <p:sldId xmlns:r="http://schemas.openxmlformats.org/officeDocument/2006/relationships" id="266" r:id="R56372632a92e4f35"/>
+    <p:sldId xmlns:r="http://schemas.openxmlformats.org/officeDocument/2006/relationships" id="267" r:id="R4c98dccb33214065"/>
+    <p:sldId xmlns:r="http://schemas.openxmlformats.org/officeDocument/2006/relationships" id="268" r:id="R7207dba7ab904bd6"/>
+    <p:sldId xmlns:r="http://schemas.openxmlformats.org/officeDocument/2006/relationships" id="269" r:id="R1ddd382839a64ae1"/>
+    <p:sldId xmlns:r="http://schemas.openxmlformats.org/officeDocument/2006/relationships" id="270" r:id="R50cbed68ae784604"/>
+    <p:sldId xmlns:r="http://schemas.openxmlformats.org/officeDocument/2006/relationships" id="271" r:id="Rd399d46df3e24107"/>
   </p:sldIdLst>
   <p:sldSz cx="9144000" cy="5143500"/>
   <p:notesSz cx="6858000" cy="9144000"/>
   <p:embeddedFontLst>
     <p:embeddedFont>
       <p:font typeface="Nunito SemiBold"/>
-      <p:regular xmlns:r="http://schemas.openxmlformats.org/officeDocument/2006/relationships" r:id="Re905cf3332df4ae9"/>
-      <p:bold xmlns:r="http://schemas.openxmlformats.org/officeDocument/2006/relationships" r:id="R4a6739e7ae3a433b"/>
-      <p:italic xmlns:r="http://schemas.openxmlformats.org/officeDocument/2006/relationships" r:id="R24ba4534808d4c49"/>
-      <p:boldItalic xmlns:r="http://schemas.openxmlformats.org/officeDocument/2006/relationships" r:id="R8c466b2471874306"/>
+      <p:regular xmlns:r="http://schemas.openxmlformats.org/officeDocument/2006/relationships" r:id="R38f9f1da8130483b"/>
+      <p:bold xmlns:r="http://schemas.openxmlformats.org/officeDocument/2006/relationships" r:id="R75061c5a8e054332"/>
+      <p:italic xmlns:r="http://schemas.openxmlformats.org/officeDocument/2006/relationships" r:id="R7464958ae69f47d3"/>
+      <p:boldItalic xmlns:r="http://schemas.openxmlformats.org/officeDocument/2006/relationships" r:id="R2e71d347617c4c8c"/>
     </p:embeddedFont>
     <p:embeddedFont>
       <p:font typeface="Nunito"/>
-      <p:regular xmlns:r="http://schemas.openxmlformats.org/officeDocument/2006/relationships" r:id="R1134dd2e46164822"/>
-      <p:bold xmlns:r="http://schemas.openxmlformats.org/officeDocument/2006/relationships" r:id="R1b143b8f69a44e45"/>
-      <p:italic xmlns:r="http://schemas.openxmlformats.org/officeDocument/2006/relationships" r:id="R44c11e4098a14a37"/>
-      <p:boldItalic xmlns:r="http://schemas.openxmlformats.org/officeDocument/2006/relationships" r:id="R26f0e551679f4e26"/>
+      <p:regular xmlns:r="http://schemas.openxmlformats.org/officeDocument/2006/relationships" r:id="R3b8011a3cd434392"/>
+      <p:bold xmlns:r="http://schemas.openxmlformats.org/officeDocument/2006/relationships" r:id="R38b5656df09640e5"/>
+      <p:italic xmlns:r="http://schemas.openxmlformats.org/officeDocument/2006/relationships" r:id="R97f262cb2cf64534"/>
+      <p:boldItalic xmlns:r="http://schemas.openxmlformats.org/officeDocument/2006/relationships" r:id="R67ebf95834a142bd"/>
     </p:embeddedFont>
     <p:embeddedFont>
       <p:font typeface="Nunito ExtraBold"/>
-      <p:bold xmlns:r="http://schemas.openxmlformats.org/officeDocument/2006/relationships" r:id="R7ace0557626f419a"/>
-      <p:boldItalic xmlns:r="http://schemas.openxmlformats.org/officeDocument/2006/relationships" r:id="Ra4f51b829c914f6d"/>
+      <p:bold xmlns:r="http://schemas.openxmlformats.org/officeDocument/2006/relationships" r:id="R045480195eb446ea"/>
+      <p:boldItalic xmlns:r="http://schemas.openxmlformats.org/officeDocument/2006/relationships" r:id="Reb25009dfd084bbe"/>
     </p:embeddedFont>
   </p:embeddedFontLst>
 </p:presentation>
@@ -732,6 +732,63 @@
               <a:buNone/>
             </a:pPr>
             <a:r>
+              <a:t>- User-provided Great Learning support response: Streamlit Community Cloud deployment is acceptable and HF subscription is optional.</a:t>
+            </a:r>
+            <a:endParaRPr/>
+          </a:p>
+          <a:p xmlns:a="http://schemas.openxmlformats.org/drawingml/2006/main">
+            <a:pPr marL="0" lvl="0" indent="0" algn="l">
+              <a:lnSpc>
+                <a:spcPct val="100000"/>
+              </a:lnSpc>
+              <a:spcBef>
+                <a:spcPts val="0"/>
+              </a:spcBef>
+              <a:spcAft>
+                <a:spcPts val="0"/>
+              </a:spcAft>
+              <a:buSzPts val="1100"/>
+              <a:buNone/>
+            </a:pPr>
+            <a:r>
+              <a:t>- Streamlit Docs: https://docs.streamlit.io/deploy/streamlit-community-cloud/deploy-your-app/deploy</a:t>
+            </a:r>
+            <a:endParaRPr/>
+          </a:p>
+          <a:p xmlns:a="http://schemas.openxmlformats.org/drawingml/2006/main">
+            <a:pPr marL="0" lvl="0" indent="0" algn="l">
+              <a:lnSpc>
+                <a:spcPct val="100000"/>
+              </a:lnSpc>
+              <a:spcBef>
+                <a:spcPts val="0"/>
+              </a:spcBef>
+              <a:spcAft>
+                <a:spcPts val="0"/>
+              </a:spcAft>
+              <a:buSzPts val="1100"/>
+              <a:buNone/>
+            </a:pPr>
+            <a:r>
+              <a:t>- Hugging Face Docs: https://huggingface.co/docs/hub/spaces-sdks-static</a:t>
+            </a:r>
+            <a:endParaRPr/>
+          </a:p>
+          <a:p xmlns:a="http://schemas.openxmlformats.org/drawingml/2006/main">
+            <a:pPr marL="0" lvl="0" indent="0" algn="l">
+              <a:lnSpc>
+                <a:spcPct val="100000"/>
+              </a:lnSpc>
+              <a:spcBef>
+                <a:spcPts val="0"/>
+              </a:spcBef>
+              <a:spcAft>
+                <a:spcPts val="0"/>
+              </a:spcAft>
+              <a:buSzPts val="1100"/>
+              <a:buNone/>
+            </a:pPr>
+            <a:r>
               <a:t>- criteria rubrics.extracted.txt: Deployment scoring requirements.</a:t>
             </a:r>
             <a:endParaRPr/>
@@ -1014,7 +1071,26 @@
               <a:buNone/>
             </a:pPr>
             <a:r>
-              <a:t>- Pending user inputs: final GitHub repository full name and Hugging Face username.</a:t>
+              <a:t>- User-provided GitHub repository and Hugging Face username.</a:t>
+            </a:r>
+            <a:endParaRPr/>
+          </a:p>
+          <a:p xmlns:a="http://schemas.openxmlformats.org/drawingml/2006/main">
+            <a:pPr marL="0" lvl="0" indent="0" algn="l">
+              <a:lnSpc>
+                <a:spcPct val="100000"/>
+              </a:lnSpc>
+              <a:spcBef>
+                <a:spcPts val="0"/>
+              </a:spcBef>
+              <a:spcAft>
+                <a:spcPts val="0"/>
+              </a:spcAft>
+              <a:buSzPts val="1100"/>
+              <a:buNone/>
+            </a:pPr>
+            <a:r>
+              <a:t>- User-provided Great Learning support response: Streamlit Community Cloud deployment details are acceptable.</a:t>
             </a:r>
             <a:endParaRPr/>
           </a:p>
@@ -4176,7 +4252,7 @@
           <p:nvPr/>
         </p:nvPicPr>
         <p:blipFill rotWithShape="1">
-          <a:blip xmlns:r="http://schemas.openxmlformats.org/officeDocument/2006/relationships" xmlns:a="http://schemas.openxmlformats.org/drawingml/2006/main" r:embed="R61933f65c03d4066">
+          <a:blip xmlns:r="http://schemas.openxmlformats.org/officeDocument/2006/relationships" xmlns:a="http://schemas.openxmlformats.org/drawingml/2006/main" r:embed="R5299a479ed7f426e">
             <a:alphaModFix/>
           </a:blip>
           <a:srcRect xmlns:a="http://schemas.openxmlformats.org/drawingml/2006/main" l="42816" t="18359" r="37297" b="19152"/>
@@ -4503,7 +4579,7 @@
           <p:nvPr/>
         </p:nvPicPr>
         <p:blipFill rotWithShape="1">
-          <a:blip xmlns:r="http://schemas.openxmlformats.org/officeDocument/2006/relationships" xmlns:a="http://schemas.openxmlformats.org/drawingml/2006/main" r:embed="Rcaa32d713922459a">
+          <a:blip xmlns:r="http://schemas.openxmlformats.org/officeDocument/2006/relationships" xmlns:a="http://schemas.openxmlformats.org/drawingml/2006/main" r:embed="Rbfdfcbc6bd934978">
             <a:alphaModFix/>
           </a:blip>
           <a:srcRect xmlns:a="http://schemas.openxmlformats.org/drawingml/2006/main" l="0" t="0" r="0" b="0"/>
@@ -13028,17 +13104,17 @@
   </p:cSld>
   <p:clrMap bg1="lt1" tx1="dk1" bg2="dk2" tx2="lt2" accent1="accent1" accent2="accent2" accent3="accent3" accent4="accent4" accent5="accent5" accent6="accent6" hlink="hlink" folHlink="folHlink"/>
   <p:sldLayoutIdLst>
-    <p:sldLayoutId xmlns:r="http://schemas.openxmlformats.org/officeDocument/2006/relationships" id="2147483649" r:id="R96e5c51f57264256"/>
-    <p:sldLayoutId xmlns:r="http://schemas.openxmlformats.org/officeDocument/2006/relationships" id="2147483650" r:id="R9733a20547c14fba"/>
-    <p:sldLayoutId xmlns:r="http://schemas.openxmlformats.org/officeDocument/2006/relationships" id="2147483651" r:id="R303c4e61983b4ac5"/>
-    <p:sldLayoutId xmlns:r="http://schemas.openxmlformats.org/officeDocument/2006/relationships" id="2147483652" r:id="R8a311f71ef914d27"/>
-    <p:sldLayoutId xmlns:r="http://schemas.openxmlformats.org/officeDocument/2006/relationships" id="2147483653" r:id="R38b414e382c44710"/>
-    <p:sldLayoutId xmlns:r="http://schemas.openxmlformats.org/officeDocument/2006/relationships" id="2147483654" r:id="R0f7749c45ef24cbe"/>
-    <p:sldLayoutId xmlns:r="http://schemas.openxmlformats.org/officeDocument/2006/relationships" id="2147483655" r:id="Rc2c0eca44a8448c4"/>
-    <p:sldLayoutId xmlns:r="http://schemas.openxmlformats.org/officeDocument/2006/relationships" id="2147483656" r:id="Re42ab44341e142ad"/>
-    <p:sldLayoutId xmlns:r="http://schemas.openxmlformats.org/officeDocument/2006/relationships" id="2147483657" r:id="Re3afd29db9514ad1"/>
-    <p:sldLayoutId xmlns:r="http://schemas.openxmlformats.org/officeDocument/2006/relationships" id="2147483658" r:id="Rac086b42c31c44ec"/>
-    <p:sldLayoutId xmlns:r="http://schemas.openxmlformats.org/officeDocument/2006/relationships" id="2147483659" r:id="R41e66fdc480247f6"/>
+    <p:sldLayoutId xmlns:r="http://schemas.openxmlformats.org/officeDocument/2006/relationships" id="2147483649" r:id="Red74d6f773a344d5"/>
+    <p:sldLayoutId xmlns:r="http://schemas.openxmlformats.org/officeDocument/2006/relationships" id="2147483650" r:id="R3a19b4a6f18248d9"/>
+    <p:sldLayoutId xmlns:r="http://schemas.openxmlformats.org/officeDocument/2006/relationships" id="2147483651" r:id="R480fdab7e68f4e65"/>
+    <p:sldLayoutId xmlns:r="http://schemas.openxmlformats.org/officeDocument/2006/relationships" id="2147483652" r:id="R4f1554b333e04309"/>
+    <p:sldLayoutId xmlns:r="http://schemas.openxmlformats.org/officeDocument/2006/relationships" id="2147483653" r:id="Rb1f6d5b1d4c245e2"/>
+    <p:sldLayoutId xmlns:r="http://schemas.openxmlformats.org/officeDocument/2006/relationships" id="2147483654" r:id="Re442222c608241ce"/>
+    <p:sldLayoutId xmlns:r="http://schemas.openxmlformats.org/officeDocument/2006/relationships" id="2147483655" r:id="R4f0b6aa0a0964714"/>
+    <p:sldLayoutId xmlns:r="http://schemas.openxmlformats.org/officeDocument/2006/relationships" id="2147483656" r:id="R9d81e14200444f8a"/>
+    <p:sldLayoutId xmlns:r="http://schemas.openxmlformats.org/officeDocument/2006/relationships" id="2147483657" r:id="R1ac7cf194cb24815"/>
+    <p:sldLayoutId xmlns:r="http://schemas.openxmlformats.org/officeDocument/2006/relationships" id="2147483658" r:id="R52f9c90db3ae4a8e"/>
+    <p:sldLayoutId xmlns:r="http://schemas.openxmlformats.org/officeDocument/2006/relationships" id="2147483659" r:id="Rb30ee16a65ab4071"/>
   </p:sldLayoutIdLst>
   <p:hf sldNum="0" hdr="0" ftr="0" dt="0"/>
   <p:txStyles>
@@ -14603,7 +14679,7 @@
           <p:nvPr/>
         </p:nvPicPr>
         <p:blipFill rotWithShape="1">
-          <a:blip xmlns:r="http://schemas.openxmlformats.org/officeDocument/2006/relationships" xmlns:a="http://schemas.openxmlformats.org/drawingml/2006/main" r:embed="R4f7c0f02ad8e4005">
+          <a:blip xmlns:r="http://schemas.openxmlformats.org/officeDocument/2006/relationships" xmlns:a="http://schemas.openxmlformats.org/drawingml/2006/main" r:embed="R63cab8c4c16a4375">
             <a:alphaModFix/>
           </a:blip>
           <a:srcRect xmlns:a="http://schemas.openxmlformats.org/drawingml/2006/main" l="0" t="0" r="0" b="0"/>
@@ -14758,16 +14834,16 @@
   </p:cSld>
   <p:clrMap bg1="lt1" tx1="dk1" bg2="dk2" tx2="lt2" accent1="accent1" accent2="accent2" accent3="accent3" accent4="accent4" accent5="accent5" accent6="accent6" hlink="hlink" folHlink="folHlink"/>
   <p:sldLayoutIdLst>
-    <p:sldLayoutId xmlns:r="http://schemas.openxmlformats.org/officeDocument/2006/relationships" id="2147483661" r:id="R77d1c79bc0b84aba"/>
-    <p:sldLayoutId xmlns:r="http://schemas.openxmlformats.org/officeDocument/2006/relationships" id="2147483662" r:id="Rb6b02f496e4e4088"/>
-    <p:sldLayoutId xmlns:r="http://schemas.openxmlformats.org/officeDocument/2006/relationships" id="2147483663" r:id="Red9a54882378489a"/>
-    <p:sldLayoutId xmlns:r="http://schemas.openxmlformats.org/officeDocument/2006/relationships" id="2147483664" r:id="R189c56501abf49c2"/>
-    <p:sldLayoutId xmlns:r="http://schemas.openxmlformats.org/officeDocument/2006/relationships" id="2147483665" r:id="Raf2ad7522fda456c"/>
-    <p:sldLayoutId xmlns:r="http://schemas.openxmlformats.org/officeDocument/2006/relationships" id="2147483666" r:id="R17b0633c69904070"/>
-    <p:sldLayoutId xmlns:r="http://schemas.openxmlformats.org/officeDocument/2006/relationships" id="2147483667" r:id="R8e8af4d7df194664"/>
-    <p:sldLayoutId xmlns:r="http://schemas.openxmlformats.org/officeDocument/2006/relationships" id="2147483668" r:id="R239fa25572714edf"/>
-    <p:sldLayoutId xmlns:r="http://schemas.openxmlformats.org/officeDocument/2006/relationships" id="2147483669" r:id="Red16c12068e847ba"/>
-    <p:sldLayoutId xmlns:r="http://schemas.openxmlformats.org/officeDocument/2006/relationships" id="2147483670" r:id="R30fa8972cc82468b"/>
+    <p:sldLayoutId xmlns:r="http://schemas.openxmlformats.org/officeDocument/2006/relationships" id="2147483661" r:id="Rd3e66ff8cb1c4f8f"/>
+    <p:sldLayoutId xmlns:r="http://schemas.openxmlformats.org/officeDocument/2006/relationships" id="2147483662" r:id="Rf7df69e26df34b62"/>
+    <p:sldLayoutId xmlns:r="http://schemas.openxmlformats.org/officeDocument/2006/relationships" id="2147483663" r:id="R6e5e4ea5a7e14d1f"/>
+    <p:sldLayoutId xmlns:r="http://schemas.openxmlformats.org/officeDocument/2006/relationships" id="2147483664" r:id="Rbc7a9b9c6b794fcb"/>
+    <p:sldLayoutId xmlns:r="http://schemas.openxmlformats.org/officeDocument/2006/relationships" id="2147483665" r:id="Rd8e1f79873654e98"/>
+    <p:sldLayoutId xmlns:r="http://schemas.openxmlformats.org/officeDocument/2006/relationships" id="2147483666" r:id="R8a62c6ba0f6c48bf"/>
+    <p:sldLayoutId xmlns:r="http://schemas.openxmlformats.org/officeDocument/2006/relationships" id="2147483667" r:id="R41c964618465458e"/>
+    <p:sldLayoutId xmlns:r="http://schemas.openxmlformats.org/officeDocument/2006/relationships" id="2147483668" r:id="R0e6af12678074b3c"/>
+    <p:sldLayoutId xmlns:r="http://schemas.openxmlformats.org/officeDocument/2006/relationships" id="2147483669" r:id="R76e1f109b6ae47be"/>
+    <p:sldLayoutId xmlns:r="http://schemas.openxmlformats.org/officeDocument/2006/relationships" id="2147483670" r:id="R3190a0cd883a43eb"/>
   </p:sldLayoutIdLst>
   <p:hf sldNum="0" hdr="0" ftr="0" dt="0"/>
   <p:txStyles>
@@ -16359,7 +16435,7 @@
                   <a:srgbClr val="1B1B1B"/>
                 </a:solidFill>
               </a:rPr>
-              <a:t>•  Deployment surface: Streamlit app packaged with a Dockerfile for Hugging Face Spaces.</a:t>
+              <a:t>•  Deployment surface: Streamlit Community Cloud app, with Hugging Face hosting script and Space files retained for portability.</a:t>
             </a:r>
           </a:p>
           <a:p xmlns:a="http://schemas.openxmlformats.org/drawingml/2006/main">
@@ -16379,7 +16455,7 @@
                   <a:srgbClr val="1B1B1B"/>
                 </a:solidFill>
               </a:rPr>
-              <a:t>•  The app downloads the registered model bundle from Hugging Face Model Hub at startup.</a:t>
+              <a:t>•  The app loads the registered model artifact from Hugging Face Model Hub.</a:t>
             </a:r>
           </a:p>
           <a:p xmlns:a="http://schemas.openxmlformats.org/drawingml/2006/main">
@@ -16439,7 +16515,7 @@
                   <a:srgbClr val="1B1B1B"/>
                 </a:solidFill>
               </a:rPr>
-              <a:t>•  Hugging Face Space target: mazin903/tourism-package-prediction</a:t>
+              <a:t>•  Accepted deployment path: Streamlit app launched directly from the GitHub repository.</a:t>
             </a:r>
           </a:p>
         </p:txBody>
@@ -16891,7 +16967,7 @@
                   <a:srgbClr val="1B1B1B"/>
                 </a:solidFill>
               </a:rPr>
-              <a:t>•  Streamlit app on Hugging Face Space: https://huggingface.co/spaces/mazin903/tourism-package-prediction</a:t>
+              <a:t>•  Streamlit app deployment: Streamlit Community Cloud, using the GitHub repository and Hugging Face model.</a:t>
             </a:r>
           </a:p>
           <a:p xmlns:a="http://schemas.openxmlformats.org/drawingml/2006/main">
@@ -16911,7 +16987,27 @@
                   <a:srgbClr val="1B1B1B"/>
                 </a:solidFill>
               </a:rPr>
-              <a:t>•  Screenshots to capture after first account run: repo folder structure, green GitHub Actions workflow, Hugging Face dataset/model pages, and Streamlit app result.</a:t>
+              <a:t>•  Hugging Face prediction app backup: https://huggingface.co/spaces/mazin903/tourism-package-prediction</a:t>
+            </a:r>
+          </a:p>
+          <a:p xmlns:a="http://schemas.openxmlformats.org/drawingml/2006/main">
+            <a:pPr>
+              <a:spcAft>
+                <a:spcPts val="8"/>
+              </a:spcAft>
+              <a:defRPr sz="1163">
+                <a:solidFill>
+                  <a:srgbClr val="1B1B1B"/>
+                </a:solidFill>
+              </a:defRPr>
+            </a:pPr>
+            <a:r>
+              <a:rPr sz="1163">
+                <a:solidFill>
+                  <a:srgbClr val="1B1B1B"/>
+                </a:solidFill>
+              </a:rPr>
+              <a:t>•  Screenshots to capture after first account run: repo folder structure, green GitHub Actions workflow, Hugging Face dataset/model pages, and prediction app result.</a:t>
             </a:r>
           </a:p>
         </p:txBody>
@@ -16947,7 +17043,7 @@
           <p:nvPr/>
         </p:nvPicPr>
         <p:blipFill rotWithShape="1">
-          <a:blip xmlns:r="http://schemas.openxmlformats.org/officeDocument/2006/relationships" xmlns:a="http://schemas.openxmlformats.org/drawingml/2006/main" r:embed="R2a77bf71dad9442c">
+          <a:blip xmlns:r="http://schemas.openxmlformats.org/officeDocument/2006/relationships" xmlns:a="http://schemas.openxmlformats.org/drawingml/2006/main" r:embed="R7432e0369f7941c0">
             <a:alphaModFix/>
           </a:blip>
           <a:srcRect xmlns:a="http://schemas.openxmlformats.org/drawingml/2006/main" l="0" t="0" r="0" b="0"/>
@@ -17666,7 +17762,7 @@
                   <a:srgbClr val="1B1B1B"/>
                 </a:solidFill>
               </a:rPr>
-              <a:t>•  Step 4: push Streamlit deployment files to Hugging Face Spaces and commit generated reports back to main.</a:t>
+              <a:t>•  Step 4: push deployment files to Hugging Face Spaces and commit generated reports back to main.</a:t>
             </a:r>
           </a:p>
         </p:txBody>
@@ -18112,7 +18208,7 @@
                   <a:srgbClr val="1B1B1B"/>
                 </a:solidFill>
               </a:rPr>
-              <a:t>•  A completed MLOps pipeline now registers data, cleans and splits it, trains a tuned XGBoost model, and packages a deployable Streamlit app.</a:t>
+              <a:t>•  A completed MLOps pipeline now registers data, cleans and splits it, trains a tuned XGBoost model, and publishes a Hugging Face prediction app.</a:t>
             </a:r>
           </a:p>
           <a:p xmlns:a="http://schemas.openxmlformats.org/drawingml/2006/main">

</xml_diff>